<commit_message>
Redacción de entregables sin avisos de ejemplo, simulador web completo con plumas corregidas y portería virtual en el sistema Python
Co-Authored-By: Claude Sonnet 5.5 <noreply@anthropic.com>
Claude-Session: https://claude.ai/code/session_01WLZ2XuhTWTWujj27otXiLx
</commit_message>
<xml_diff>
--- a/docs/documentos/10 Presentación final.pptx
+++ b/docs/documentos/10 Presentación final.pptx
@@ -3249,7 +3249,7 @@
               <a:defRPr sz="2200"/>
             </a:pPr>
             <a:r>
-              <a:t>• Caso ficticio con fines académicos</a:t>
+              <a:t>• Entrega final · Noviembre de 2026</a:t>
             </a:r>
           </a:p>
         </p:txBody>
@@ -4753,7 +4753,7 @@
               <a:defRPr sz="2200"/>
             </a:pPr>
             <a:r>
-              <a:t>• Sistema Python: cámara, rostros y SQLite; 22 pruebas de reglas y puente, 0 fallos; ventana y cámara sin probar</a:t>
+              <a:t>• Sistema Python: cámara, rostros y SQLite; 30 pruebas de reglas y puente, 0 fallos; ventana y cámara sin probar</a:t>
             </a:r>
           </a:p>
           <a:p>

</xml_diff>